<commit_message>
Add AYNO Bot autonomous robot + advanced tech upgrades (LoRa, SNN, mesh, edge-fog-cloud) to PPT, README, STATUS
</commit_message>
<xml_diff>
--- a/Ecoverse_360_Presentation.pptx
+++ b/Ecoverse_360_Presentation.pptx
@@ -19,6 +19,8 @@
     <p:sldId id="267" r:id="rId18"/>
     <p:sldId id="268" r:id="rId19"/>
     <p:sldId id="269" r:id="rId20"/>
+    <p:sldId id="270" r:id="rId21"/>
+    <p:sldId id="271" r:id="rId22"/>
   </p:sldIdLst>
   <p:sldSz cx="12191695" cy="6858000" type="screen4x3"/>
   <p:notesSz cx="6858000" cy="9144000"/>
@@ -3611,7 +3613,7 @@
               </a:defRPr>
             </a:pPr>
             <a:r>
-              <a:t>1/14</a:t>
+              <a:t>1/16</a:t>
             </a:r>
           </a:p>
         </p:txBody>
@@ -5066,7 +5068,7 @@
               </a:defRPr>
             </a:pPr>
             <a:r>
-              <a:t>10/14</a:t>
+              <a:t>10/16</a:t>
             </a:r>
           </a:p>
         </p:txBody>
@@ -7758,7 +7760,7 @@
               </a:defRPr>
             </a:pPr>
             <a:r>
-              <a:t>11/14</a:t>
+              <a:t>11/16</a:t>
             </a:r>
           </a:p>
         </p:txBody>
@@ -9647,7 +9649,7 @@
               </a:defRPr>
             </a:pPr>
             <a:r>
-              <a:t>12/14</a:t>
+              <a:t>12/16</a:t>
             </a:r>
           </a:p>
         </p:txBody>
@@ -11237,7 +11239,7 @@
               </a:defRPr>
             </a:pPr>
             <a:r>
-              <a:t>13/14</a:t>
+              <a:t>13/16</a:t>
             </a:r>
           </a:p>
         </p:txBody>
@@ -11251,6 +11253,2415 @@
 </file>
 
 <file path=ppt/slides/slide14.xml><?xml version="1.0" encoding="utf-8"?>
+<p:sld xmlns:a="http://schemas.openxmlformats.org/drawingml/2006/main" xmlns:p="http://schemas.openxmlformats.org/presentationml/2006/main" xmlns:r="http://schemas.openxmlformats.org/officeDocument/2006/relationships">
+  <p:cSld>
+    <p:bg>
+      <p:bgPr>
+        <a:solidFill>
+          <a:srgbClr val="FFFFFF"/>
+        </a:solidFill>
+        <a:effectLst/>
+      </p:bgPr>
+    </p:bg>
+    <p:spTree>
+      <p:nvGrpSpPr>
+        <p:cNvPr id="1" name=""/>
+        <p:cNvGrpSpPr/>
+        <p:nvPr/>
+      </p:nvGrpSpPr>
+      <p:grpSpPr/>
+      <p:sp>
+        <p:nvSpPr>
+          <p:cNvPr id="2" name="Rectangle 1"/>
+          <p:cNvSpPr/>
+          <p:nvPr/>
+        </p:nvSpPr>
+        <p:spPr>
+          <a:xfrm>
+            <a:off x="0" y="0"/>
+            <a:ext cx="12191695" cy="914400"/>
+          </a:xfrm>
+          <a:prstGeom prst="rect">
+            <a:avLst/>
+          </a:prstGeom>
+          <a:solidFill>
+            <a:srgbClr val="084C2E"/>
+          </a:solidFill>
+          <a:ln>
+            <a:noFill/>
+          </a:ln>
+        </p:spPr>
+        <p:style>
+          <a:lnRef idx="1">
+            <a:schemeClr val="accent1"/>
+          </a:lnRef>
+          <a:fillRef idx="3">
+            <a:schemeClr val="accent1"/>
+          </a:fillRef>
+          <a:effectRef idx="2">
+            <a:schemeClr val="accent1"/>
+          </a:effectRef>
+          <a:fontRef idx="minor">
+            <a:schemeClr val="lt1"/>
+          </a:fontRef>
+        </p:style>
+        <p:txBody>
+          <a:bodyPr rtlCol="0" anchor="ctr"/>
+          <a:lstStyle/>
+          <a:p>
+            <a:pPr algn="ctr"/>
+          </a:p>
+        </p:txBody>
+      </p:sp>
+      <p:sp>
+        <p:nvSpPr>
+          <p:cNvPr id="3" name="TextBox 2"/>
+          <p:cNvSpPr txBox="1"/>
+          <p:nvPr/>
+        </p:nvSpPr>
+        <p:spPr>
+          <a:xfrm>
+            <a:off x="548640" y="109728"/>
+            <a:ext cx="9144000" cy="640080"/>
+          </a:xfrm>
+          <a:prstGeom prst="rect">
+            <a:avLst/>
+          </a:prstGeom>
+          <a:noFill/>
+        </p:spPr>
+        <p:txBody>
+          <a:bodyPr wrap="square">
+            <a:spAutoFit/>
+          </a:bodyPr>
+          <a:lstStyle/>
+          <a:p>
+            <a:pPr algn="l">
+              <a:defRPr sz="2800" b="1">
+                <a:solidFill>
+                  <a:srgbClr val="FFFFFF"/>
+                </a:solidFill>
+                <a:latin typeface="Calibri"/>
+              </a:defRPr>
+            </a:pPr>
+            <a:r>
+              <a:t>AYNO BOT — AUTONOMOUS GARDEN ROBOT</a:t>
+            </a:r>
+          </a:p>
+        </p:txBody>
+      </p:sp>
+      <p:sp>
+        <p:nvSpPr>
+          <p:cNvPr id="4" name="TextBox 3"/>
+          <p:cNvSpPr txBox="1"/>
+          <p:nvPr/>
+        </p:nvSpPr>
+        <p:spPr>
+          <a:xfrm>
+            <a:off x="548640" y="502920"/>
+            <a:ext cx="9144000" cy="365760"/>
+          </a:xfrm>
+          <a:prstGeom prst="rect">
+            <a:avLst/>
+          </a:prstGeom>
+          <a:noFill/>
+        </p:spPr>
+        <p:txBody>
+          <a:bodyPr wrap="square">
+            <a:spAutoFit/>
+          </a:bodyPr>
+          <a:lstStyle/>
+          <a:p>
+            <a:pPr algn="l">
+              <a:defRPr sz="1300" b="0">
+                <a:solidFill>
+                  <a:srgbClr val="D3F8DF"/>
+                </a:solidFill>
+                <a:latin typeface="Calibri"/>
+              </a:defRPr>
+            </a:pPr>
+            <a:r>
+              <a:t>A mobile extension of Ecoverse 360 — gardening, harvesting, cleaning, guarding</a:t>
+            </a:r>
+          </a:p>
+        </p:txBody>
+      </p:sp>
+      <p:sp>
+        <p:nvSpPr>
+          <p:cNvPr id="5" name="Oval 4"/>
+          <p:cNvSpPr/>
+          <p:nvPr/>
+        </p:nvSpPr>
+        <p:spPr>
+          <a:xfrm>
+            <a:off x="11338560" y="228600"/>
+            <a:ext cx="457200" cy="457200"/>
+          </a:xfrm>
+          <a:prstGeom prst="ellipse">
+            <a:avLst/>
+          </a:prstGeom>
+          <a:solidFill>
+            <a:srgbClr val="16B364"/>
+          </a:solidFill>
+          <a:ln>
+            <a:noFill/>
+          </a:ln>
+        </p:spPr>
+        <p:style>
+          <a:lnRef idx="1">
+            <a:schemeClr val="accent1"/>
+          </a:lnRef>
+          <a:fillRef idx="3">
+            <a:schemeClr val="accent1"/>
+          </a:fillRef>
+          <a:effectRef idx="2">
+            <a:schemeClr val="accent1"/>
+          </a:effectRef>
+          <a:fontRef idx="minor">
+            <a:schemeClr val="lt1"/>
+          </a:fontRef>
+        </p:style>
+        <p:txBody>
+          <a:bodyPr rtlCol="0" anchor="ctr"/>
+          <a:lstStyle/>
+          <a:p>
+            <a:pPr algn="ctr"/>
+          </a:p>
+        </p:txBody>
+      </p:sp>
+      <p:sp>
+        <p:nvSpPr>
+          <p:cNvPr id="6" name="Rounded Rectangle 5"/>
+          <p:cNvSpPr/>
+          <p:nvPr/>
+        </p:nvSpPr>
+        <p:spPr>
+          <a:xfrm>
+            <a:off x="365760" y="1188720"/>
+            <a:ext cx="5669280" cy="5212080"/>
+          </a:xfrm>
+          <a:prstGeom prst="roundRect">
+            <a:avLst/>
+          </a:prstGeom>
+          <a:solidFill>
+            <a:srgbClr val="FFFFFF"/>
+          </a:solidFill>
+          <a:ln w="12700">
+            <a:solidFill>
+              <a:srgbClr val="E5E7EB"/>
+            </a:solidFill>
+          </a:ln>
+        </p:spPr>
+        <p:style>
+          <a:lnRef idx="1">
+            <a:schemeClr val="accent1"/>
+          </a:lnRef>
+          <a:fillRef idx="3">
+            <a:schemeClr val="accent1"/>
+          </a:fillRef>
+          <a:effectRef idx="2">
+            <a:schemeClr val="accent1"/>
+          </a:effectRef>
+          <a:fontRef idx="minor">
+            <a:schemeClr val="lt1"/>
+          </a:fontRef>
+        </p:style>
+        <p:txBody>
+          <a:bodyPr rtlCol="0" anchor="ctr"/>
+          <a:lstStyle/>
+          <a:p>
+            <a:pPr algn="ctr"/>
+          </a:p>
+        </p:txBody>
+      </p:sp>
+      <p:sp>
+        <p:nvSpPr>
+          <p:cNvPr id="7" name="Rectangle 6"/>
+          <p:cNvSpPr/>
+          <p:nvPr/>
+        </p:nvSpPr>
+        <p:spPr>
+          <a:xfrm>
+            <a:off x="365760" y="1188720"/>
+            <a:ext cx="5669280" cy="64008"/>
+          </a:xfrm>
+          <a:prstGeom prst="rect">
+            <a:avLst/>
+          </a:prstGeom>
+          <a:solidFill>
+            <a:srgbClr val="16B364"/>
+          </a:solidFill>
+          <a:ln>
+            <a:noFill/>
+          </a:ln>
+        </p:spPr>
+        <p:style>
+          <a:lnRef idx="1">
+            <a:schemeClr val="accent1"/>
+          </a:lnRef>
+          <a:fillRef idx="3">
+            <a:schemeClr val="accent1"/>
+          </a:fillRef>
+          <a:effectRef idx="2">
+            <a:schemeClr val="accent1"/>
+          </a:effectRef>
+          <a:fontRef idx="minor">
+            <a:schemeClr val="lt1"/>
+          </a:fontRef>
+        </p:style>
+        <p:txBody>
+          <a:bodyPr rtlCol="0" anchor="ctr"/>
+          <a:lstStyle/>
+          <a:p>
+            <a:pPr algn="ctr"/>
+          </a:p>
+        </p:txBody>
+      </p:sp>
+      <p:sp>
+        <p:nvSpPr>
+          <p:cNvPr id="8" name="TextBox 7"/>
+          <p:cNvSpPr txBox="1"/>
+          <p:nvPr/>
+        </p:nvSpPr>
+        <p:spPr>
+          <a:xfrm>
+            <a:off x="640080" y="1325880"/>
+            <a:ext cx="5029200" cy="365760"/>
+          </a:xfrm>
+          <a:prstGeom prst="rect">
+            <a:avLst/>
+          </a:prstGeom>
+          <a:noFill/>
+        </p:spPr>
+        <p:txBody>
+          <a:bodyPr wrap="square">
+            <a:spAutoFit/>
+          </a:bodyPr>
+          <a:lstStyle/>
+          <a:p>
+            <a:pPr algn="l">
+              <a:defRPr sz="1800" b="1">
+                <a:solidFill>
+                  <a:srgbClr val="084C2E"/>
+                </a:solidFill>
+                <a:latin typeface="Calibri"/>
+              </a:defRPr>
+            </a:pPr>
+            <a:r>
+              <a:t>5 Roles, 1 Robot</a:t>
+            </a:r>
+          </a:p>
+        </p:txBody>
+      </p:sp>
+      <p:sp>
+        <p:nvSpPr>
+          <p:cNvPr id="9" name="TextBox 8"/>
+          <p:cNvSpPr txBox="1"/>
+          <p:nvPr/>
+        </p:nvSpPr>
+        <p:spPr>
+          <a:xfrm>
+            <a:off x="640080" y="1783080"/>
+            <a:ext cx="5120640" cy="4389120"/>
+          </a:xfrm>
+          <a:prstGeom prst="rect">
+            <a:avLst/>
+          </a:prstGeom>
+          <a:noFill/>
+        </p:spPr>
+        <p:txBody>
+          <a:bodyPr wrap="square">
+            <a:spAutoFit/>
+          </a:bodyPr>
+          <a:lstStyle/>
+          <a:p>
+            <a:pPr>
+              <a:spcAft>
+                <a:spcPts val="300"/>
+              </a:spcAft>
+              <a:defRPr sz="1100">
+                <a:solidFill>
+                  <a:srgbClr val="6B7280"/>
+                </a:solidFill>
+                <a:latin typeface="Calibri"/>
+              </a:defRPr>
+            </a:pPr>
+            <a:r>
+              <a:t>GARDENER — Soil moisture probing, automated watering with</a:t>
+            </a:r>
+          </a:p>
+          <a:p>
+            <a:pPr>
+              <a:spcAft>
+                <a:spcPts val="300"/>
+              </a:spcAft>
+              <a:defRPr sz="1100">
+                <a:solidFill>
+                  <a:srgbClr val="6B7280"/>
+                </a:solidFill>
+                <a:latin typeface="Calibri"/>
+              </a:defRPr>
+            </a:pPr>
+            <a:r>
+              <a:t>  small onboard tank, precision irrigation from soil data</a:t>
+            </a:r>
+          </a:p>
+          <a:p>
+            <a:pPr>
+              <a:spcAft>
+                <a:spcPts val="300"/>
+              </a:spcAft>
+              <a:defRPr sz="1100">
+                <a:solidFill>
+                  <a:srgbClr val="6B7280"/>
+                </a:solidFill>
+                <a:latin typeface="Calibri"/>
+              </a:defRPr>
+            </a:pPr>
+          </a:p>
+          <a:p>
+            <a:pPr>
+              <a:spcAft>
+                <a:spcPts val="300"/>
+              </a:spcAft>
+              <a:defRPr sz="1100">
+                <a:solidFill>
+                  <a:srgbClr val="6B7280"/>
+                </a:solidFill>
+                <a:latin typeface="Calibri"/>
+              </a:defRPr>
+            </a:pPr>
+            <a:r>
+              <a:t>HARVESTER — Soft-grip robotic arm collects nutmeg/fruit,</a:t>
+            </a:r>
+          </a:p>
+          <a:p>
+            <a:pPr>
+              <a:spcAft>
+                <a:spcPts val="300"/>
+              </a:spcAft>
+              <a:defRPr sz="1100">
+                <a:solidFill>
+                  <a:srgbClr val="6B7280"/>
+                </a:solidFill>
+                <a:latin typeface="Calibri"/>
+              </a:defRPr>
+            </a:pPr>
+            <a:r>
+              <a:t>  per-tree yield tracking, daily harvest reports</a:t>
+            </a:r>
+          </a:p>
+          <a:p>
+            <a:pPr>
+              <a:spcAft>
+                <a:spcPts val="300"/>
+              </a:spcAft>
+              <a:defRPr sz="1100">
+                <a:solidFill>
+                  <a:srgbClr val="6B7280"/>
+                </a:solidFill>
+                <a:latin typeface="Calibri"/>
+              </a:defRPr>
+            </a:pPr>
+          </a:p>
+          <a:p>
+            <a:pPr>
+              <a:spcAft>
+                <a:spcPts val="300"/>
+              </a:spcAft>
+              <a:defRPr sz="1100">
+                <a:solidFill>
+                  <a:srgbClr val="6B7280"/>
+                </a:solidFill>
+                <a:latin typeface="Calibri"/>
+              </a:defRPr>
+            </a:pPr>
+            <a:r>
+              <a:t>PLANT DOCTOR — RGB camera + AI scans leaves for decay,</a:t>
+            </a:r>
+          </a:p>
+          <a:p>
+            <a:pPr>
+              <a:spcAft>
+                <a:spcPts val="300"/>
+              </a:spcAft>
+              <a:defRPr sz="1100">
+                <a:solidFill>
+                  <a:srgbClr val="6B7280"/>
+                </a:solidFill>
+                <a:latin typeface="Calibri"/>
+              </a:defRPr>
+            </a:pPr>
+            <a:r>
+              <a:t>  disease, nutrient deficiency — early warning alerts</a:t>
+            </a:r>
+          </a:p>
+          <a:p>
+            <a:pPr>
+              <a:spcAft>
+                <a:spcPts val="300"/>
+              </a:spcAft>
+              <a:defRPr sz="1100">
+                <a:solidFill>
+                  <a:srgbClr val="6B7280"/>
+                </a:solidFill>
+                <a:latin typeface="Calibri"/>
+              </a:defRPr>
+            </a:pPr>
+          </a:p>
+          <a:p>
+            <a:pPr>
+              <a:spcAft>
+                <a:spcPts val="300"/>
+              </a:spcAft>
+              <a:defRPr sz="1100">
+                <a:solidFill>
+                  <a:srgbClr val="6B7280"/>
+                </a:solidFill>
+                <a:latin typeface="Calibri"/>
+              </a:defRPr>
+            </a:pPr>
+            <a:r>
+              <a:t>CLEANER — Scheduled front-area sweeping (morning + evening),</a:t>
+            </a:r>
+          </a:p>
+          <a:p>
+            <a:pPr>
+              <a:spcAft>
+                <a:spcPts val="300"/>
+              </a:spcAft>
+              <a:defRPr sz="1100">
+                <a:solidFill>
+                  <a:srgbClr val="6B7280"/>
+                </a:solidFill>
+                <a:latin typeface="Calibri"/>
+              </a:defRPr>
+            </a:pPr>
+            <a:r>
+              <a:t>  user-selectable cleaning zones via mobile app</a:t>
+            </a:r>
+          </a:p>
+          <a:p>
+            <a:pPr>
+              <a:spcAft>
+                <a:spcPts val="300"/>
+              </a:spcAft>
+              <a:defRPr sz="1100">
+                <a:solidFill>
+                  <a:srgbClr val="6B7280"/>
+                </a:solidFill>
+                <a:latin typeface="Calibri"/>
+              </a:defRPr>
+            </a:pPr>
+          </a:p>
+          <a:p>
+            <a:pPr>
+              <a:spcAft>
+                <a:spcPts val="300"/>
+              </a:spcAft>
+              <a:defRPr sz="1100">
+                <a:solidFill>
+                  <a:srgbClr val="6B7280"/>
+                </a:solidFill>
+                <a:latin typeface="Calibri"/>
+              </a:defRPr>
+            </a:pPr>
+            <a:r>
+              <a:t>GUARD &amp; PET — Person detection, friendly voice greeting,</a:t>
+            </a:r>
+          </a:p>
+          <a:p>
+            <a:pPr>
+              <a:spcAft>
+                <a:spcPts val="300"/>
+              </a:spcAft>
+              <a:defRPr sz="1100">
+                <a:solidFill>
+                  <a:srgbClr val="6B7280"/>
+                </a:solidFill>
+                <a:latin typeface="Calibri"/>
+              </a:defRPr>
+            </a:pPr>
+            <a:r>
+              <a:t>  unknown-presence alerts, camera recording</a:t>
+            </a:r>
+          </a:p>
+        </p:txBody>
+      </p:sp>
+      <p:sp>
+        <p:nvSpPr>
+          <p:cNvPr id="10" name="Rounded Rectangle 9"/>
+          <p:cNvSpPr/>
+          <p:nvPr/>
+        </p:nvSpPr>
+        <p:spPr>
+          <a:xfrm>
+            <a:off x="6217920" y="1188720"/>
+            <a:ext cx="5669280" cy="2560320"/>
+          </a:xfrm>
+          <a:prstGeom prst="roundRect">
+            <a:avLst/>
+          </a:prstGeom>
+          <a:solidFill>
+            <a:srgbClr val="FFFFFF"/>
+          </a:solidFill>
+          <a:ln w="12700">
+            <a:solidFill>
+              <a:srgbClr val="E5E7EB"/>
+            </a:solidFill>
+          </a:ln>
+        </p:spPr>
+        <p:style>
+          <a:lnRef idx="1">
+            <a:schemeClr val="accent1"/>
+          </a:lnRef>
+          <a:fillRef idx="3">
+            <a:schemeClr val="accent1"/>
+          </a:fillRef>
+          <a:effectRef idx="2">
+            <a:schemeClr val="accent1"/>
+          </a:effectRef>
+          <a:fontRef idx="minor">
+            <a:schemeClr val="lt1"/>
+          </a:fontRef>
+        </p:style>
+        <p:txBody>
+          <a:bodyPr rtlCol="0" anchor="ctr"/>
+          <a:lstStyle/>
+          <a:p>
+            <a:pPr algn="ctr"/>
+          </a:p>
+        </p:txBody>
+      </p:sp>
+      <p:sp>
+        <p:nvSpPr>
+          <p:cNvPr id="11" name="Rectangle 10"/>
+          <p:cNvSpPr/>
+          <p:nvPr/>
+        </p:nvSpPr>
+        <p:spPr>
+          <a:xfrm>
+            <a:off x="6217920" y="1188720"/>
+            <a:ext cx="5669280" cy="64008"/>
+          </a:xfrm>
+          <a:prstGeom prst="rect">
+            <a:avLst/>
+          </a:prstGeom>
+          <a:solidFill>
+            <a:srgbClr val="3B82F6"/>
+          </a:solidFill>
+          <a:ln>
+            <a:noFill/>
+          </a:ln>
+        </p:spPr>
+        <p:style>
+          <a:lnRef idx="1">
+            <a:schemeClr val="accent1"/>
+          </a:lnRef>
+          <a:fillRef idx="3">
+            <a:schemeClr val="accent1"/>
+          </a:fillRef>
+          <a:effectRef idx="2">
+            <a:schemeClr val="accent1"/>
+          </a:effectRef>
+          <a:fontRef idx="minor">
+            <a:schemeClr val="lt1"/>
+          </a:fontRef>
+        </p:style>
+        <p:txBody>
+          <a:bodyPr rtlCol="0" anchor="ctr"/>
+          <a:lstStyle/>
+          <a:p>
+            <a:pPr algn="ctr"/>
+          </a:p>
+        </p:txBody>
+      </p:sp>
+      <p:sp>
+        <p:nvSpPr>
+          <p:cNvPr id="12" name="TextBox 11"/>
+          <p:cNvSpPr txBox="1"/>
+          <p:nvPr/>
+        </p:nvSpPr>
+        <p:spPr>
+          <a:xfrm>
+            <a:off x="6492240" y="1325880"/>
+            <a:ext cx="5029200" cy="365760"/>
+          </a:xfrm>
+          <a:prstGeom prst="rect">
+            <a:avLst/>
+          </a:prstGeom>
+          <a:noFill/>
+        </p:spPr>
+        <p:txBody>
+          <a:bodyPr wrap="square">
+            <a:spAutoFit/>
+          </a:bodyPr>
+          <a:lstStyle/>
+          <a:p>
+            <a:pPr algn="l">
+              <a:defRPr sz="1600" b="1">
+                <a:solidFill>
+                  <a:srgbClr val="084C2E"/>
+                </a:solidFill>
+                <a:latin typeface="Calibri"/>
+              </a:defRPr>
+            </a:pPr>
+            <a:r>
+              <a:t>Brain Architecture</a:t>
+            </a:r>
+          </a:p>
+        </p:txBody>
+      </p:sp>
+      <p:sp>
+        <p:nvSpPr>
+          <p:cNvPr id="13" name="TextBox 12"/>
+          <p:cNvSpPr txBox="1"/>
+          <p:nvPr/>
+        </p:nvSpPr>
+        <p:spPr>
+          <a:xfrm>
+            <a:off x="6492240" y="1783080"/>
+            <a:ext cx="5120640" cy="1828800"/>
+          </a:xfrm>
+          <a:prstGeom prst="rect">
+            <a:avLst/>
+          </a:prstGeom>
+          <a:noFill/>
+        </p:spPr>
+        <p:txBody>
+          <a:bodyPr wrap="square">
+            <a:spAutoFit/>
+          </a:bodyPr>
+          <a:lstStyle/>
+          <a:p>
+            <a:pPr>
+              <a:spcAft>
+                <a:spcPts val="500"/>
+              </a:spcAft>
+              <a:defRPr sz="1100">
+                <a:solidFill>
+                  <a:srgbClr val="6B7280"/>
+                </a:solidFill>
+                <a:latin typeface="Calibri"/>
+              </a:defRPr>
+            </a:pPr>
+            <a:r>
+              <a:t>Mobile App (WiFi)  —  mapping, reports, manual override</a:t>
+            </a:r>
+          </a:p>
+          <a:p>
+            <a:pPr>
+              <a:spcAft>
+                <a:spcPts val="500"/>
+              </a:spcAft>
+              <a:defRPr sz="1100">
+                <a:solidFill>
+                  <a:srgbClr val="6B7280"/>
+                </a:solidFill>
+                <a:latin typeface="Calibri"/>
+              </a:defRPr>
+            </a:pPr>
+            <a:r>
+              <a:t>       ↓</a:t>
+            </a:r>
+          </a:p>
+          <a:p>
+            <a:pPr>
+              <a:spcAft>
+                <a:spcPts val="500"/>
+              </a:spcAft>
+              <a:defRPr sz="1100">
+                <a:solidFill>
+                  <a:srgbClr val="6B7280"/>
+                </a:solidFill>
+                <a:latin typeface="Calibri"/>
+              </a:defRPr>
+            </a:pPr>
+            <a:r>
+              <a:t>Edge AI (Jetson/RPi)  —  SLAM, leaf AI, path planning</a:t>
+            </a:r>
+          </a:p>
+          <a:p>
+            <a:pPr>
+              <a:spcAft>
+                <a:spcPts val="500"/>
+              </a:spcAft>
+              <a:defRPr sz="1100">
+                <a:solidFill>
+                  <a:srgbClr val="6B7280"/>
+                </a:solidFill>
+                <a:latin typeface="Calibri"/>
+              </a:defRPr>
+            </a:pPr>
+            <a:r>
+              <a:t>       ↓  UART / CAN</a:t>
+            </a:r>
+          </a:p>
+          <a:p>
+            <a:pPr>
+              <a:spcAft>
+                <a:spcPts val="500"/>
+              </a:spcAft>
+              <a:defRPr sz="1100">
+                <a:solidFill>
+                  <a:srgbClr val="6B7280"/>
+                </a:solidFill>
+                <a:latin typeface="Calibri"/>
+              </a:defRPr>
+            </a:pPr>
+            <a:r>
+              <a:t>RT MCU (ESP32/STM32)  —  motors, encoders, arm, sensors</a:t>
+            </a:r>
+          </a:p>
+        </p:txBody>
+      </p:sp>
+      <p:sp>
+        <p:nvSpPr>
+          <p:cNvPr id="14" name="Rounded Rectangle 13"/>
+          <p:cNvSpPr/>
+          <p:nvPr/>
+        </p:nvSpPr>
+        <p:spPr>
+          <a:xfrm>
+            <a:off x="6217920" y="3931920"/>
+            <a:ext cx="5669280" cy="2468880"/>
+          </a:xfrm>
+          <a:prstGeom prst="roundRect">
+            <a:avLst/>
+          </a:prstGeom>
+          <a:solidFill>
+            <a:srgbClr val="FFFFFF"/>
+          </a:solidFill>
+          <a:ln w="12700">
+            <a:solidFill>
+              <a:srgbClr val="E5E7EB"/>
+            </a:solidFill>
+          </a:ln>
+        </p:spPr>
+        <p:style>
+          <a:lnRef idx="1">
+            <a:schemeClr val="accent1"/>
+          </a:lnRef>
+          <a:fillRef idx="3">
+            <a:schemeClr val="accent1"/>
+          </a:fillRef>
+          <a:effectRef idx="2">
+            <a:schemeClr val="accent1"/>
+          </a:effectRef>
+          <a:fontRef idx="minor">
+            <a:schemeClr val="lt1"/>
+          </a:fontRef>
+        </p:style>
+        <p:txBody>
+          <a:bodyPr rtlCol="0" anchor="ctr"/>
+          <a:lstStyle/>
+          <a:p>
+            <a:pPr algn="ctr"/>
+          </a:p>
+        </p:txBody>
+      </p:sp>
+      <p:sp>
+        <p:nvSpPr>
+          <p:cNvPr id="15" name="Rectangle 14"/>
+          <p:cNvSpPr/>
+          <p:nvPr/>
+        </p:nvSpPr>
+        <p:spPr>
+          <a:xfrm>
+            <a:off x="6217920" y="3931920"/>
+            <a:ext cx="5669280" cy="64008"/>
+          </a:xfrm>
+          <a:prstGeom prst="rect">
+            <a:avLst/>
+          </a:prstGeom>
+          <a:solidFill>
+            <a:srgbClr val="14B8A6"/>
+          </a:solidFill>
+          <a:ln>
+            <a:noFill/>
+          </a:ln>
+        </p:spPr>
+        <p:style>
+          <a:lnRef idx="1">
+            <a:schemeClr val="accent1"/>
+          </a:lnRef>
+          <a:fillRef idx="3">
+            <a:schemeClr val="accent1"/>
+          </a:fillRef>
+          <a:effectRef idx="2">
+            <a:schemeClr val="accent1"/>
+          </a:effectRef>
+          <a:fontRef idx="minor">
+            <a:schemeClr val="lt1"/>
+          </a:fontRef>
+        </p:style>
+        <p:txBody>
+          <a:bodyPr rtlCol="0" anchor="ctr"/>
+          <a:lstStyle/>
+          <a:p>
+            <a:pPr algn="ctr"/>
+          </a:p>
+        </p:txBody>
+      </p:sp>
+      <p:sp>
+        <p:nvSpPr>
+          <p:cNvPr id="16" name="TextBox 15"/>
+          <p:cNvSpPr txBox="1"/>
+          <p:nvPr/>
+        </p:nvSpPr>
+        <p:spPr>
+          <a:xfrm>
+            <a:off x="6492240" y="4069080"/>
+            <a:ext cx="5029200" cy="365760"/>
+          </a:xfrm>
+          <a:prstGeom prst="rect">
+            <a:avLst/>
+          </a:prstGeom>
+          <a:noFill/>
+        </p:spPr>
+        <p:txBody>
+          <a:bodyPr wrap="square">
+            <a:spAutoFit/>
+          </a:bodyPr>
+          <a:lstStyle/>
+          <a:p>
+            <a:pPr algn="l">
+              <a:defRPr sz="1600" b="1">
+                <a:solidFill>
+                  <a:srgbClr val="084C2E"/>
+                </a:solidFill>
+                <a:latin typeface="Calibri"/>
+              </a:defRPr>
+            </a:pPr>
+            <a:r>
+              <a:t>Key Technical Details</a:t>
+            </a:r>
+          </a:p>
+        </p:txBody>
+      </p:sp>
+      <p:sp>
+        <p:nvSpPr>
+          <p:cNvPr id="17" name="TextBox 16"/>
+          <p:cNvSpPr txBox="1"/>
+          <p:nvPr/>
+        </p:nvSpPr>
+        <p:spPr>
+          <a:xfrm>
+            <a:off x="6492240" y="4526280"/>
+            <a:ext cx="5120640" cy="1737360"/>
+          </a:xfrm>
+          <a:prstGeom prst="rect">
+            <a:avLst/>
+          </a:prstGeom>
+          <a:noFill/>
+        </p:spPr>
+        <p:txBody>
+          <a:bodyPr wrap="square">
+            <a:spAutoFit/>
+          </a:bodyPr>
+          <a:lstStyle/>
+          <a:p>
+            <a:pPr>
+              <a:spcAft>
+                <a:spcPts val="300"/>
+              </a:spcAft>
+              <a:defRPr sz="1000">
+                <a:solidFill>
+                  <a:srgbClr val="6B7280"/>
+                </a:solidFill>
+                <a:latin typeface="Calibri"/>
+              </a:defRPr>
+            </a:pPr>
+            <a:r>
+              <a:t>• 4-wheel differential drive + quadrature encoders</a:t>
+            </a:r>
+          </a:p>
+          <a:p>
+            <a:pPr>
+              <a:spcAft>
+                <a:spcPts val="300"/>
+              </a:spcAft>
+              <a:defRPr sz="1000">
+                <a:solidFill>
+                  <a:srgbClr val="6B7280"/>
+                </a:solidFill>
+                <a:latin typeface="Calibri"/>
+              </a:defRPr>
+            </a:pPr>
+            <a:r>
+              <a:t>• 2D LiDAR SLAM + IMU + wheel odometry</a:t>
+            </a:r>
+          </a:p>
+          <a:p>
+            <a:pPr>
+              <a:spcAft>
+                <a:spcPts val="300"/>
+              </a:spcAft>
+              <a:defRPr sz="1000">
+                <a:solidFill>
+                  <a:srgbClr val="6B7280"/>
+                </a:solidFill>
+                <a:latin typeface="Calibri"/>
+              </a:defRPr>
+            </a:pPr>
+            <a:r>
+              <a:t>• Cost-based path planning (distance + battery + water)</a:t>
+            </a:r>
+          </a:p>
+          <a:p>
+            <a:pPr>
+              <a:spcAft>
+                <a:spcPts val="300"/>
+              </a:spcAft>
+              <a:defRPr sz="1000">
+                <a:solidFill>
+                  <a:srgbClr val="6B7280"/>
+                </a:solidFill>
+                <a:latin typeface="Calibri"/>
+              </a:defRPr>
+            </a:pPr>
+            <a:r>
+              <a:t>• 4-5 DOF arm with swappable end effectors</a:t>
+            </a:r>
+          </a:p>
+          <a:p>
+            <a:pPr>
+              <a:spcAft>
+                <a:spcPts val="300"/>
+              </a:spcAft>
+              <a:defRPr sz="1000">
+                <a:solidFill>
+                  <a:srgbClr val="6B7280"/>
+                </a:solidFill>
+                <a:latin typeface="Calibri"/>
+              </a:defRPr>
+            </a:pPr>
+            <a:r>
+              <a:t>• WiFi-controlled tap refill for water tank</a:t>
+            </a:r>
+          </a:p>
+          <a:p>
+            <a:pPr>
+              <a:spcAft>
+                <a:spcPts val="300"/>
+              </a:spcAft>
+              <a:defRPr sz="1000">
+                <a:solidFill>
+                  <a:srgbClr val="6B7280"/>
+                </a:solidFill>
+                <a:latin typeface="Calibri"/>
+              </a:defRPr>
+            </a:pPr>
+            <a:r>
+              <a:t>• ArUco/AprilTag auto-dock charging station</a:t>
+            </a:r>
+          </a:p>
+          <a:p>
+            <a:pPr>
+              <a:spcAft>
+                <a:spcPts val="300"/>
+              </a:spcAft>
+              <a:defRPr sz="1000">
+                <a:solidFill>
+                  <a:srgbClr val="6B7280"/>
+                </a:solidFill>
+                <a:latin typeface="Calibri"/>
+              </a:defRPr>
+            </a:pPr>
+            <a:r>
+              <a:t>• Per-tree SLAM mapping with plant health profiles</a:t>
+            </a:r>
+          </a:p>
+          <a:p>
+            <a:pPr>
+              <a:spcAft>
+                <a:spcPts val="300"/>
+              </a:spcAft>
+              <a:defRPr sz="1000">
+                <a:solidFill>
+                  <a:srgbClr val="6B7280"/>
+                </a:solidFill>
+                <a:latin typeface="Calibri"/>
+              </a:defRPr>
+            </a:pPr>
+            <a:r>
+              <a:t>• Feeds data into Ecoverse Digital Twin ecosystem</a:t>
+            </a:r>
+          </a:p>
+        </p:txBody>
+      </p:sp>
+      <p:sp>
+        <p:nvSpPr>
+          <p:cNvPr id="18" name="TextBox 17"/>
+          <p:cNvSpPr txBox="1"/>
+          <p:nvPr/>
+        </p:nvSpPr>
+        <p:spPr>
+          <a:xfrm>
+            <a:off x="11155680" y="6446520"/>
+            <a:ext cx="914400" cy="365760"/>
+          </a:xfrm>
+          <a:prstGeom prst="rect">
+            <a:avLst/>
+          </a:prstGeom>
+          <a:noFill/>
+        </p:spPr>
+        <p:txBody>
+          <a:bodyPr wrap="square">
+            <a:spAutoFit/>
+          </a:bodyPr>
+          <a:lstStyle/>
+          <a:p>
+            <a:pPr algn="r">
+              <a:defRPr sz="1000" b="0">
+                <a:solidFill>
+                  <a:srgbClr val="6B7280"/>
+                </a:solidFill>
+                <a:latin typeface="Calibri"/>
+              </a:defRPr>
+            </a:pPr>
+            <a:r>
+              <a:t>14/16</a:t>
+            </a:r>
+          </a:p>
+        </p:txBody>
+      </p:sp>
+    </p:spTree>
+  </p:cSld>
+  <p:clrMapOvr>
+    <a:masterClrMapping/>
+  </p:clrMapOvr>
+</p:sld>
+</file>
+
+<file path=ppt/slides/slide15.xml><?xml version="1.0" encoding="utf-8"?>
+<p:sld xmlns:a="http://schemas.openxmlformats.org/drawingml/2006/main" xmlns:p="http://schemas.openxmlformats.org/presentationml/2006/main" xmlns:r="http://schemas.openxmlformats.org/officeDocument/2006/relationships">
+  <p:cSld>
+    <p:bg>
+      <p:bgPr>
+        <a:solidFill>
+          <a:srgbClr val="FFFFFF"/>
+        </a:solidFill>
+        <a:effectLst/>
+      </p:bgPr>
+    </p:bg>
+    <p:spTree>
+      <p:nvGrpSpPr>
+        <p:cNvPr id="1" name=""/>
+        <p:cNvGrpSpPr/>
+        <p:nvPr/>
+      </p:nvGrpSpPr>
+      <p:grpSpPr/>
+      <p:sp>
+        <p:nvSpPr>
+          <p:cNvPr id="2" name="Rectangle 1"/>
+          <p:cNvSpPr/>
+          <p:nvPr/>
+        </p:nvSpPr>
+        <p:spPr>
+          <a:xfrm>
+            <a:off x="0" y="0"/>
+            <a:ext cx="12191695" cy="914400"/>
+          </a:xfrm>
+          <a:prstGeom prst="rect">
+            <a:avLst/>
+          </a:prstGeom>
+          <a:solidFill>
+            <a:srgbClr val="084C2E"/>
+          </a:solidFill>
+          <a:ln>
+            <a:noFill/>
+          </a:ln>
+        </p:spPr>
+        <p:style>
+          <a:lnRef idx="1">
+            <a:schemeClr val="accent1"/>
+          </a:lnRef>
+          <a:fillRef idx="3">
+            <a:schemeClr val="accent1"/>
+          </a:fillRef>
+          <a:effectRef idx="2">
+            <a:schemeClr val="accent1"/>
+          </a:effectRef>
+          <a:fontRef idx="minor">
+            <a:schemeClr val="lt1"/>
+          </a:fontRef>
+        </p:style>
+        <p:txBody>
+          <a:bodyPr rtlCol="0" anchor="ctr"/>
+          <a:lstStyle/>
+          <a:p>
+            <a:pPr algn="ctr"/>
+          </a:p>
+        </p:txBody>
+      </p:sp>
+      <p:sp>
+        <p:nvSpPr>
+          <p:cNvPr id="3" name="TextBox 2"/>
+          <p:cNvSpPr txBox="1"/>
+          <p:nvPr/>
+        </p:nvSpPr>
+        <p:spPr>
+          <a:xfrm>
+            <a:off x="548640" y="109728"/>
+            <a:ext cx="9144000" cy="640080"/>
+          </a:xfrm>
+          <a:prstGeom prst="rect">
+            <a:avLst/>
+          </a:prstGeom>
+          <a:noFill/>
+        </p:spPr>
+        <p:txBody>
+          <a:bodyPr wrap="square">
+            <a:spAutoFit/>
+          </a:bodyPr>
+          <a:lstStyle/>
+          <a:p>
+            <a:pPr algn="l">
+              <a:defRPr sz="2800" b="1">
+                <a:solidFill>
+                  <a:srgbClr val="FFFFFF"/>
+                </a:solidFill>
+                <a:latin typeface="Calibri"/>
+              </a:defRPr>
+            </a:pPr>
+            <a:r>
+              <a:t>ADVANCED TECHNOLOGY ROADMAP</a:t>
+            </a:r>
+          </a:p>
+        </p:txBody>
+      </p:sp>
+      <p:sp>
+        <p:nvSpPr>
+          <p:cNvPr id="4" name="TextBox 3"/>
+          <p:cNvSpPr txBox="1"/>
+          <p:nvPr/>
+        </p:nvSpPr>
+        <p:spPr>
+          <a:xfrm>
+            <a:off x="548640" y="502920"/>
+            <a:ext cx="9144000" cy="365760"/>
+          </a:xfrm>
+          <a:prstGeom prst="rect">
+            <a:avLst/>
+          </a:prstGeom>
+          <a:noFill/>
+        </p:spPr>
+        <p:txBody>
+          <a:bodyPr wrap="square">
+            <a:spAutoFit/>
+          </a:bodyPr>
+          <a:lstStyle/>
+          <a:p>
+            <a:pPr algn="l">
+              <a:defRPr sz="1300" b="0">
+                <a:solidFill>
+                  <a:srgbClr val="D3F8DF"/>
+                </a:solidFill>
+                <a:latin typeface="Calibri"/>
+              </a:defRPr>
+            </a:pPr>
+            <a:r>
+              <a:t>Next-generation networking, edge AI, and architecture upgrades</a:t>
+            </a:r>
+          </a:p>
+        </p:txBody>
+      </p:sp>
+      <p:sp>
+        <p:nvSpPr>
+          <p:cNvPr id="5" name="Oval 4"/>
+          <p:cNvSpPr/>
+          <p:nvPr/>
+        </p:nvSpPr>
+        <p:spPr>
+          <a:xfrm>
+            <a:off x="11338560" y="228600"/>
+            <a:ext cx="457200" cy="457200"/>
+          </a:xfrm>
+          <a:prstGeom prst="ellipse">
+            <a:avLst/>
+          </a:prstGeom>
+          <a:solidFill>
+            <a:srgbClr val="16B364"/>
+          </a:solidFill>
+          <a:ln>
+            <a:noFill/>
+          </a:ln>
+        </p:spPr>
+        <p:style>
+          <a:lnRef idx="1">
+            <a:schemeClr val="accent1"/>
+          </a:lnRef>
+          <a:fillRef idx="3">
+            <a:schemeClr val="accent1"/>
+          </a:fillRef>
+          <a:effectRef idx="2">
+            <a:schemeClr val="accent1"/>
+          </a:effectRef>
+          <a:fontRef idx="minor">
+            <a:schemeClr val="lt1"/>
+          </a:fontRef>
+        </p:style>
+        <p:txBody>
+          <a:bodyPr rtlCol="0" anchor="ctr"/>
+          <a:lstStyle/>
+          <a:p>
+            <a:pPr algn="ctr"/>
+          </a:p>
+        </p:txBody>
+      </p:sp>
+      <p:sp>
+        <p:nvSpPr>
+          <p:cNvPr id="6" name="Rounded Rectangle 5"/>
+          <p:cNvSpPr/>
+          <p:nvPr/>
+        </p:nvSpPr>
+        <p:spPr>
+          <a:xfrm>
+            <a:off x="274320" y="1188720"/>
+            <a:ext cx="3749039" cy="5212080"/>
+          </a:xfrm>
+          <a:prstGeom prst="roundRect">
+            <a:avLst/>
+          </a:prstGeom>
+          <a:solidFill>
+            <a:srgbClr val="FFFFFF"/>
+          </a:solidFill>
+          <a:ln w="12700">
+            <a:solidFill>
+              <a:srgbClr val="E5E7EB"/>
+            </a:solidFill>
+          </a:ln>
+        </p:spPr>
+        <p:style>
+          <a:lnRef idx="1">
+            <a:schemeClr val="accent1"/>
+          </a:lnRef>
+          <a:fillRef idx="3">
+            <a:schemeClr val="accent1"/>
+          </a:fillRef>
+          <a:effectRef idx="2">
+            <a:schemeClr val="accent1"/>
+          </a:effectRef>
+          <a:fontRef idx="minor">
+            <a:schemeClr val="lt1"/>
+          </a:fontRef>
+        </p:style>
+        <p:txBody>
+          <a:bodyPr rtlCol="0" anchor="ctr"/>
+          <a:lstStyle/>
+          <a:p>
+            <a:pPr algn="ctr"/>
+          </a:p>
+        </p:txBody>
+      </p:sp>
+      <p:sp>
+        <p:nvSpPr>
+          <p:cNvPr id="7" name="Rectangle 6"/>
+          <p:cNvSpPr/>
+          <p:nvPr/>
+        </p:nvSpPr>
+        <p:spPr>
+          <a:xfrm>
+            <a:off x="274320" y="1188720"/>
+            <a:ext cx="3749039" cy="64008"/>
+          </a:xfrm>
+          <a:prstGeom prst="rect">
+            <a:avLst/>
+          </a:prstGeom>
+          <a:solidFill>
+            <a:srgbClr val="3B82F6"/>
+          </a:solidFill>
+          <a:ln>
+            <a:noFill/>
+          </a:ln>
+        </p:spPr>
+        <p:style>
+          <a:lnRef idx="1">
+            <a:schemeClr val="accent1"/>
+          </a:lnRef>
+          <a:fillRef idx="3">
+            <a:schemeClr val="accent1"/>
+          </a:fillRef>
+          <a:effectRef idx="2">
+            <a:schemeClr val="accent1"/>
+          </a:effectRef>
+          <a:fontRef idx="minor">
+            <a:schemeClr val="lt1"/>
+          </a:fontRef>
+        </p:style>
+        <p:txBody>
+          <a:bodyPr rtlCol="0" anchor="ctr"/>
+          <a:lstStyle/>
+          <a:p>
+            <a:pPr algn="ctr"/>
+          </a:p>
+        </p:txBody>
+      </p:sp>
+      <p:sp>
+        <p:nvSpPr>
+          <p:cNvPr id="8" name="TextBox 7"/>
+          <p:cNvSpPr txBox="1"/>
+          <p:nvPr/>
+        </p:nvSpPr>
+        <p:spPr>
+          <a:xfrm>
+            <a:off x="457200" y="1325880"/>
+            <a:ext cx="3383280" cy="365760"/>
+          </a:xfrm>
+          <a:prstGeom prst="rect">
+            <a:avLst/>
+          </a:prstGeom>
+          <a:noFill/>
+        </p:spPr>
+        <p:txBody>
+          <a:bodyPr wrap="square">
+            <a:spAutoFit/>
+          </a:bodyPr>
+          <a:lstStyle/>
+          <a:p>
+            <a:pPr algn="l">
+              <a:defRPr sz="1400" b="1">
+                <a:solidFill>
+                  <a:srgbClr val="3B82F6"/>
+                </a:solidFill>
+                <a:latin typeface="Calibri"/>
+              </a:defRPr>
+            </a:pPr>
+            <a:r>
+              <a:t>Communication &amp; Networking</a:t>
+            </a:r>
+          </a:p>
+        </p:txBody>
+      </p:sp>
+      <p:sp>
+        <p:nvSpPr>
+          <p:cNvPr id="9" name="TextBox 8"/>
+          <p:cNvSpPr txBox="1"/>
+          <p:nvPr/>
+        </p:nvSpPr>
+        <p:spPr>
+          <a:xfrm>
+            <a:off x="457200" y="1783080"/>
+            <a:ext cx="3383280" cy="4389120"/>
+          </a:xfrm>
+          <a:prstGeom prst="rect">
+            <a:avLst/>
+          </a:prstGeom>
+          <a:noFill/>
+        </p:spPr>
+        <p:txBody>
+          <a:bodyPr wrap="square">
+            <a:spAutoFit/>
+          </a:bodyPr>
+          <a:lstStyle/>
+          <a:p>
+            <a:pPr>
+              <a:spcAft>
+                <a:spcPts val="200"/>
+              </a:spcAft>
+              <a:defRPr sz="1000">
+                <a:solidFill>
+                  <a:srgbClr val="6B7280"/>
+                </a:solidFill>
+                <a:latin typeface="Calibri"/>
+              </a:defRPr>
+            </a:pPr>
+            <a:r>
+              <a:t>LoRa (Long Range)</a:t>
+            </a:r>
+          </a:p>
+          <a:p>
+            <a:pPr>
+              <a:spcAft>
+                <a:spcPts val="200"/>
+              </a:spcAft>
+              <a:defRPr sz="1000">
+                <a:solidFill>
+                  <a:srgbClr val="6B7280"/>
+                </a:solidFill>
+                <a:latin typeface="Calibri"/>
+              </a:defRPr>
+            </a:pPr>
+            <a:r>
+              <a:t>  Sub-GHz links spanning 2-15 km for remote</a:t>
+            </a:r>
+          </a:p>
+          <a:p>
+            <a:pPr>
+              <a:spcAft>
+                <a:spcPts val="200"/>
+              </a:spcAft>
+              <a:defRPr sz="1000">
+                <a:solidFill>
+                  <a:srgbClr val="6B7280"/>
+                </a:solidFill>
+                <a:latin typeface="Calibri"/>
+              </a:defRPr>
+            </a:pPr>
+            <a:r>
+              <a:t>  sensors beyond WiFi — ideal for Phase 3-4</a:t>
+            </a:r>
+          </a:p>
+          <a:p>
+            <a:pPr>
+              <a:spcAft>
+                <a:spcPts val="200"/>
+              </a:spcAft>
+              <a:defRPr sz="1000">
+                <a:solidFill>
+                  <a:srgbClr val="6B7280"/>
+                </a:solidFill>
+                <a:latin typeface="Calibri"/>
+              </a:defRPr>
+            </a:pPr>
+          </a:p>
+          <a:p>
+            <a:pPr>
+              <a:spcAft>
+                <a:spcPts val="200"/>
+              </a:spcAft>
+              <a:defRPr sz="1000">
+                <a:solidFill>
+                  <a:srgbClr val="6B7280"/>
+                </a:solidFill>
+                <a:latin typeface="Calibri"/>
+              </a:defRPr>
+            </a:pPr>
+            <a:r>
+              <a:t>LoRa Mesh / LoRaWAN</a:t>
+            </a:r>
+          </a:p>
+          <a:p>
+            <a:pPr>
+              <a:spcAft>
+                <a:spcPts val="200"/>
+              </a:spcAft>
+              <a:defRPr sz="1000">
+                <a:solidFill>
+                  <a:srgbClr val="6B7280"/>
+                </a:solidFill>
+                <a:latin typeface="Calibri"/>
+              </a:defRPr>
+            </a:pPr>
+            <a:r>
+              <a:t>  Multi-hop relay topology — extends coverage</a:t>
+            </a:r>
+          </a:p>
+          <a:p>
+            <a:pPr>
+              <a:spcAft>
+                <a:spcPts val="200"/>
+              </a:spcAft>
+              <a:defRPr sz="1000">
+                <a:solidFill>
+                  <a:srgbClr val="6B7280"/>
+                </a:solidFill>
+                <a:latin typeface="Calibri"/>
+              </a:defRPr>
+            </a:pPr>
+            <a:r>
+              <a:t>  across campuses, parks, industrial sites</a:t>
+            </a:r>
+          </a:p>
+          <a:p>
+            <a:pPr>
+              <a:spcAft>
+                <a:spcPts val="200"/>
+              </a:spcAft>
+              <a:defRPr sz="1000">
+                <a:solidFill>
+                  <a:srgbClr val="6B7280"/>
+                </a:solidFill>
+                <a:latin typeface="Calibri"/>
+              </a:defRPr>
+            </a:pPr>
+          </a:p>
+          <a:p>
+            <a:pPr>
+              <a:spcAft>
+                <a:spcPts val="200"/>
+              </a:spcAft>
+              <a:defRPr sz="1000">
+                <a:solidFill>
+                  <a:srgbClr val="6B7280"/>
+                </a:solidFill>
+                <a:latin typeface="Calibri"/>
+              </a:defRPr>
+            </a:pPr>
+            <a:r>
+              <a:t>BLE Mesh Network</a:t>
+            </a:r>
+          </a:p>
+          <a:p>
+            <a:pPr>
+              <a:spcAft>
+                <a:spcPts val="200"/>
+              </a:spcAft>
+              <a:defRPr sz="1000">
+                <a:solidFill>
+                  <a:srgbClr val="6B7280"/>
+                </a:solidFill>
+                <a:latin typeface="Calibri"/>
+              </a:defRPr>
+            </a:pPr>
+            <a:r>
+              <a:t>  Dense indoor sensor networks — occupancy</a:t>
+            </a:r>
+          </a:p>
+          <a:p>
+            <a:pPr>
+              <a:spcAft>
+                <a:spcPts val="200"/>
+              </a:spcAft>
+              <a:defRPr sz="1000">
+                <a:solidFill>
+                  <a:srgbClr val="6B7280"/>
+                </a:solidFill>
+                <a:latin typeface="Calibri"/>
+              </a:defRPr>
+            </a:pPr>
+            <a:r>
+              <a:t>  tracking, air quality mapping, HVAC control</a:t>
+            </a:r>
+          </a:p>
+          <a:p>
+            <a:pPr>
+              <a:spcAft>
+                <a:spcPts val="200"/>
+              </a:spcAft>
+              <a:defRPr sz="1000">
+                <a:solidFill>
+                  <a:srgbClr val="6B7280"/>
+                </a:solidFill>
+                <a:latin typeface="Calibri"/>
+              </a:defRPr>
+            </a:pPr>
+          </a:p>
+          <a:p>
+            <a:pPr>
+              <a:spcAft>
+                <a:spcPts val="200"/>
+              </a:spcAft>
+              <a:defRPr sz="1000">
+                <a:solidFill>
+                  <a:srgbClr val="6B7280"/>
+                </a:solidFill>
+                <a:latin typeface="Calibri"/>
+              </a:defRPr>
+            </a:pPr>
+            <a:r>
+              <a:t>OPC UA + MQTT Bridge</a:t>
+            </a:r>
+          </a:p>
+          <a:p>
+            <a:pPr>
+              <a:spcAft>
+                <a:spcPts val="200"/>
+              </a:spcAft>
+              <a:defRPr sz="1000">
+                <a:solidFill>
+                  <a:srgbClr val="6B7280"/>
+                </a:solidFill>
+                <a:latin typeface="Calibri"/>
+              </a:defRPr>
+            </a:pPr>
+            <a:r>
+              <a:t>  Industrial protocol bridging — connects</a:t>
+            </a:r>
+          </a:p>
+          <a:p>
+            <a:pPr>
+              <a:spcAft>
+                <a:spcPts val="200"/>
+              </a:spcAft>
+              <a:defRPr sz="1000">
+                <a:solidFill>
+                  <a:srgbClr val="6B7280"/>
+                </a:solidFill>
+                <a:latin typeface="Calibri"/>
+              </a:defRPr>
+            </a:pPr>
+            <a:r>
+              <a:t>  PLCs, SCADA to Ecoverse MQTT pipeline</a:t>
+            </a:r>
+          </a:p>
+        </p:txBody>
+      </p:sp>
+      <p:sp>
+        <p:nvSpPr>
+          <p:cNvPr id="10" name="Rounded Rectangle 9"/>
+          <p:cNvSpPr/>
+          <p:nvPr/>
+        </p:nvSpPr>
+        <p:spPr>
+          <a:xfrm>
+            <a:off x="4206240" y="1188720"/>
+            <a:ext cx="3749039" cy="5212080"/>
+          </a:xfrm>
+          <a:prstGeom prst="roundRect">
+            <a:avLst/>
+          </a:prstGeom>
+          <a:solidFill>
+            <a:srgbClr val="FFFFFF"/>
+          </a:solidFill>
+          <a:ln w="12700">
+            <a:solidFill>
+              <a:srgbClr val="E5E7EB"/>
+            </a:solidFill>
+          </a:ln>
+        </p:spPr>
+        <p:style>
+          <a:lnRef idx="1">
+            <a:schemeClr val="accent1"/>
+          </a:lnRef>
+          <a:fillRef idx="3">
+            <a:schemeClr val="accent1"/>
+          </a:fillRef>
+          <a:effectRef idx="2">
+            <a:schemeClr val="accent1"/>
+          </a:effectRef>
+          <a:fontRef idx="minor">
+            <a:schemeClr val="lt1"/>
+          </a:fontRef>
+        </p:style>
+        <p:txBody>
+          <a:bodyPr rtlCol="0" anchor="ctr"/>
+          <a:lstStyle/>
+          <a:p>
+            <a:pPr algn="ctr"/>
+          </a:p>
+        </p:txBody>
+      </p:sp>
+      <p:sp>
+        <p:nvSpPr>
+          <p:cNvPr id="11" name="Rectangle 10"/>
+          <p:cNvSpPr/>
+          <p:nvPr/>
+        </p:nvSpPr>
+        <p:spPr>
+          <a:xfrm>
+            <a:off x="4206240" y="1188720"/>
+            <a:ext cx="3749039" cy="64008"/>
+          </a:xfrm>
+          <a:prstGeom prst="rect">
+            <a:avLst/>
+          </a:prstGeom>
+          <a:solidFill>
+            <a:srgbClr val="9B70F1"/>
+          </a:solidFill>
+          <a:ln>
+            <a:noFill/>
+          </a:ln>
+        </p:spPr>
+        <p:style>
+          <a:lnRef idx="1">
+            <a:schemeClr val="accent1"/>
+          </a:lnRef>
+          <a:fillRef idx="3">
+            <a:schemeClr val="accent1"/>
+          </a:fillRef>
+          <a:effectRef idx="2">
+            <a:schemeClr val="accent1"/>
+          </a:effectRef>
+          <a:fontRef idx="minor">
+            <a:schemeClr val="lt1"/>
+          </a:fontRef>
+        </p:style>
+        <p:txBody>
+          <a:bodyPr rtlCol="0" anchor="ctr"/>
+          <a:lstStyle/>
+          <a:p>
+            <a:pPr algn="ctr"/>
+          </a:p>
+        </p:txBody>
+      </p:sp>
+      <p:sp>
+        <p:nvSpPr>
+          <p:cNvPr id="12" name="TextBox 11"/>
+          <p:cNvSpPr txBox="1"/>
+          <p:nvPr/>
+        </p:nvSpPr>
+        <p:spPr>
+          <a:xfrm>
+            <a:off x="4389120" y="1325880"/>
+            <a:ext cx="3383280" cy="365760"/>
+          </a:xfrm>
+          <a:prstGeom prst="rect">
+            <a:avLst/>
+          </a:prstGeom>
+          <a:noFill/>
+        </p:spPr>
+        <p:txBody>
+          <a:bodyPr wrap="square">
+            <a:spAutoFit/>
+          </a:bodyPr>
+          <a:lstStyle/>
+          <a:p>
+            <a:pPr algn="l">
+              <a:defRPr sz="1400" b="1">
+                <a:solidFill>
+                  <a:srgbClr val="9B70F1"/>
+                </a:solidFill>
+                <a:latin typeface="Calibri"/>
+              </a:defRPr>
+            </a:pPr>
+            <a:r>
+              <a:t>Edge AI &amp; Neuromorphic</a:t>
+            </a:r>
+          </a:p>
+        </p:txBody>
+      </p:sp>
+      <p:sp>
+        <p:nvSpPr>
+          <p:cNvPr id="13" name="TextBox 12"/>
+          <p:cNvSpPr txBox="1"/>
+          <p:nvPr/>
+        </p:nvSpPr>
+        <p:spPr>
+          <a:xfrm>
+            <a:off x="4389120" y="1783080"/>
+            <a:ext cx="3383280" cy="4389120"/>
+          </a:xfrm>
+          <a:prstGeom prst="rect">
+            <a:avLst/>
+          </a:prstGeom>
+          <a:noFill/>
+        </p:spPr>
+        <p:txBody>
+          <a:bodyPr wrap="square">
+            <a:spAutoFit/>
+          </a:bodyPr>
+          <a:lstStyle/>
+          <a:p>
+            <a:pPr>
+              <a:spcAft>
+                <a:spcPts val="200"/>
+              </a:spcAft>
+              <a:defRPr sz="1000">
+                <a:solidFill>
+                  <a:srgbClr val="6B7280"/>
+                </a:solidFill>
+                <a:latin typeface="Calibri"/>
+              </a:defRPr>
+            </a:pPr>
+            <a:r>
+              <a:t>SNN (Spiking Neural Networks)</a:t>
+            </a:r>
+          </a:p>
+          <a:p>
+            <a:pPr>
+              <a:spcAft>
+                <a:spcPts val="200"/>
+              </a:spcAft>
+              <a:defRPr sz="1000">
+                <a:solidFill>
+                  <a:srgbClr val="6B7280"/>
+                </a:solidFill>
+                <a:latin typeface="Calibri"/>
+              </a:defRPr>
+            </a:pPr>
+            <a:r>
+              <a:t>  Neuromorphic ultra-low-power edge AI —</a:t>
+            </a:r>
+          </a:p>
+          <a:p>
+            <a:pPr>
+              <a:spcAft>
+                <a:spcPts val="200"/>
+              </a:spcAft>
+              <a:defRPr sz="1000">
+                <a:solidFill>
+                  <a:srgbClr val="6B7280"/>
+                </a:solidFill>
+                <a:latin typeface="Calibri"/>
+              </a:defRPr>
+            </a:pPr>
+            <a:r>
+              <a:t>  event-driven, mimics biological neurons,</a:t>
+            </a:r>
+          </a:p>
+          <a:p>
+            <a:pPr>
+              <a:spcAft>
+                <a:spcPts val="200"/>
+              </a:spcAft>
+              <a:defRPr sz="1000">
+                <a:solidFill>
+                  <a:srgbClr val="6B7280"/>
+                </a:solidFill>
+                <a:latin typeface="Calibri"/>
+              </a:defRPr>
+            </a:pPr>
+            <a:r>
+              <a:t>  always-on anomaly detection without cloud</a:t>
+            </a:r>
+          </a:p>
+          <a:p>
+            <a:pPr>
+              <a:spcAft>
+                <a:spcPts val="200"/>
+              </a:spcAft>
+              <a:defRPr sz="1000">
+                <a:solidFill>
+                  <a:srgbClr val="6B7280"/>
+                </a:solidFill>
+                <a:latin typeface="Calibri"/>
+              </a:defRPr>
+            </a:pPr>
+          </a:p>
+          <a:p>
+            <a:pPr>
+              <a:spcAft>
+                <a:spcPts val="200"/>
+              </a:spcAft>
+              <a:defRPr sz="1000">
+                <a:solidFill>
+                  <a:srgbClr val="6B7280"/>
+                </a:solidFill>
+                <a:latin typeface="Calibri"/>
+              </a:defRPr>
+            </a:pPr>
+            <a:r>
+              <a:t>TinyML</a:t>
+            </a:r>
+          </a:p>
+          <a:p>
+            <a:pPr>
+              <a:spcAft>
+                <a:spcPts val="200"/>
+              </a:spcAft>
+              <a:defRPr sz="1000">
+                <a:solidFill>
+                  <a:srgbClr val="6B7280"/>
+                </a:solidFill>
+                <a:latin typeface="Calibri"/>
+              </a:defRPr>
+            </a:pPr>
+            <a:r>
+              <a:t>  Quantized ML on ESP32/STM32 —</a:t>
+            </a:r>
+          </a:p>
+          <a:p>
+            <a:pPr>
+              <a:spcAft>
+                <a:spcPts val="200"/>
+              </a:spcAft>
+              <a:defRPr sz="1000">
+                <a:solidFill>
+                  <a:srgbClr val="6B7280"/>
+                </a:solidFill>
+                <a:latin typeface="Calibri"/>
+              </a:defRPr>
+            </a:pPr>
+            <a:r>
+              <a:t>  on-device waste classification, anomaly</a:t>
+            </a:r>
+          </a:p>
+          <a:p>
+            <a:pPr>
+              <a:spcAft>
+                <a:spcPts val="200"/>
+              </a:spcAft>
+              <a:defRPr sz="1000">
+                <a:solidFill>
+                  <a:srgbClr val="6B7280"/>
+                </a:solidFill>
+                <a:latin typeface="Calibri"/>
+              </a:defRPr>
+            </a:pPr>
+            <a:r>
+              <a:t>  detection, predictive alerts, zero latency</a:t>
+            </a:r>
+          </a:p>
+          <a:p>
+            <a:pPr>
+              <a:spcAft>
+                <a:spcPts val="200"/>
+              </a:spcAft>
+              <a:defRPr sz="1000">
+                <a:solidFill>
+                  <a:srgbClr val="6B7280"/>
+                </a:solidFill>
+                <a:latin typeface="Calibri"/>
+              </a:defRPr>
+            </a:pPr>
+          </a:p>
+          <a:p>
+            <a:pPr>
+              <a:spcAft>
+                <a:spcPts val="200"/>
+              </a:spcAft>
+              <a:defRPr sz="1000">
+                <a:solidFill>
+                  <a:srgbClr val="6B7280"/>
+                </a:solidFill>
+                <a:latin typeface="Calibri"/>
+              </a:defRPr>
+            </a:pPr>
+            <a:r>
+              <a:t>Federated Learning</a:t>
+            </a:r>
+          </a:p>
+          <a:p>
+            <a:pPr>
+              <a:spcAft>
+                <a:spcPts val="200"/>
+              </a:spcAft>
+              <a:defRPr sz="1000">
+                <a:solidFill>
+                  <a:srgbClr val="6B7280"/>
+                </a:solidFill>
+                <a:latin typeface="Calibri"/>
+              </a:defRPr>
+            </a:pPr>
+            <a:r>
+              <a:t>  Cross-site model training without sharing</a:t>
+            </a:r>
+          </a:p>
+          <a:p>
+            <a:pPr>
+              <a:spcAft>
+                <a:spcPts val="200"/>
+              </a:spcAft>
+              <a:defRPr sz="1000">
+                <a:solidFill>
+                  <a:srgbClr val="6B7280"/>
+                </a:solidFill>
+                <a:latin typeface="Calibri"/>
+              </a:defRPr>
+            </a:pPr>
+            <a:r>
+              <a:t>  raw data — privacy-preserving, bandwidth-</a:t>
+            </a:r>
+          </a:p>
+          <a:p>
+            <a:pPr>
+              <a:spcAft>
+                <a:spcPts val="200"/>
+              </a:spcAft>
+              <a:defRPr sz="1000">
+                <a:solidFill>
+                  <a:srgbClr val="6B7280"/>
+                </a:solidFill>
+                <a:latin typeface="Calibri"/>
+              </a:defRPr>
+            </a:pPr>
+            <a:r>
+              <a:t>  efficient, campus-specific adaptation</a:t>
+            </a:r>
+          </a:p>
+        </p:txBody>
+      </p:sp>
+      <p:sp>
+        <p:nvSpPr>
+          <p:cNvPr id="14" name="Rounded Rectangle 13"/>
+          <p:cNvSpPr/>
+          <p:nvPr/>
+        </p:nvSpPr>
+        <p:spPr>
+          <a:xfrm>
+            <a:off x="8138160" y="1188720"/>
+            <a:ext cx="3749039" cy="5212080"/>
+          </a:xfrm>
+          <a:prstGeom prst="roundRect">
+            <a:avLst/>
+          </a:prstGeom>
+          <a:solidFill>
+            <a:srgbClr val="FFFFFF"/>
+          </a:solidFill>
+          <a:ln w="12700">
+            <a:solidFill>
+              <a:srgbClr val="E5E7EB"/>
+            </a:solidFill>
+          </a:ln>
+        </p:spPr>
+        <p:style>
+          <a:lnRef idx="1">
+            <a:schemeClr val="accent1"/>
+          </a:lnRef>
+          <a:fillRef idx="3">
+            <a:schemeClr val="accent1"/>
+          </a:fillRef>
+          <a:effectRef idx="2">
+            <a:schemeClr val="accent1"/>
+          </a:effectRef>
+          <a:fontRef idx="minor">
+            <a:schemeClr val="lt1"/>
+          </a:fontRef>
+        </p:style>
+        <p:txBody>
+          <a:bodyPr rtlCol="0" anchor="ctr"/>
+          <a:lstStyle/>
+          <a:p>
+            <a:pPr algn="ctr"/>
+          </a:p>
+        </p:txBody>
+      </p:sp>
+      <p:sp>
+        <p:nvSpPr>
+          <p:cNvPr id="15" name="Rectangle 14"/>
+          <p:cNvSpPr/>
+          <p:nvPr/>
+        </p:nvSpPr>
+        <p:spPr>
+          <a:xfrm>
+            <a:off x="8138160" y="1188720"/>
+            <a:ext cx="3749039" cy="64008"/>
+          </a:xfrm>
+          <a:prstGeom prst="rect">
+            <a:avLst/>
+          </a:prstGeom>
+          <a:solidFill>
+            <a:srgbClr val="14B8A6"/>
+          </a:solidFill>
+          <a:ln>
+            <a:noFill/>
+          </a:ln>
+        </p:spPr>
+        <p:style>
+          <a:lnRef idx="1">
+            <a:schemeClr val="accent1"/>
+          </a:lnRef>
+          <a:fillRef idx="3">
+            <a:schemeClr val="accent1"/>
+          </a:fillRef>
+          <a:effectRef idx="2">
+            <a:schemeClr val="accent1"/>
+          </a:effectRef>
+          <a:fontRef idx="minor">
+            <a:schemeClr val="lt1"/>
+          </a:fontRef>
+        </p:style>
+        <p:txBody>
+          <a:bodyPr rtlCol="0" anchor="ctr"/>
+          <a:lstStyle/>
+          <a:p>
+            <a:pPr algn="ctr"/>
+          </a:p>
+        </p:txBody>
+      </p:sp>
+      <p:sp>
+        <p:nvSpPr>
+          <p:cNvPr id="16" name="TextBox 15"/>
+          <p:cNvSpPr txBox="1"/>
+          <p:nvPr/>
+        </p:nvSpPr>
+        <p:spPr>
+          <a:xfrm>
+            <a:off x="8321040" y="1325880"/>
+            <a:ext cx="3383280" cy="365760"/>
+          </a:xfrm>
+          <a:prstGeom prst="rect">
+            <a:avLst/>
+          </a:prstGeom>
+          <a:noFill/>
+        </p:spPr>
+        <p:txBody>
+          <a:bodyPr wrap="square">
+            <a:spAutoFit/>
+          </a:bodyPr>
+          <a:lstStyle/>
+          <a:p>
+            <a:pPr algn="l">
+              <a:defRPr sz="1400" b="1">
+                <a:solidFill>
+                  <a:srgbClr val="14B8A6"/>
+                </a:solidFill>
+                <a:latin typeface="Calibri"/>
+              </a:defRPr>
+            </a:pPr>
+            <a:r>
+              <a:t>Architecture &amp; Simulation</a:t>
+            </a:r>
+          </a:p>
+        </p:txBody>
+      </p:sp>
+      <p:sp>
+        <p:nvSpPr>
+          <p:cNvPr id="17" name="TextBox 16"/>
+          <p:cNvSpPr txBox="1"/>
+          <p:nvPr/>
+        </p:nvSpPr>
+        <p:spPr>
+          <a:xfrm>
+            <a:off x="8321040" y="1783080"/>
+            <a:ext cx="3383280" cy="4389120"/>
+          </a:xfrm>
+          <a:prstGeom prst="rect">
+            <a:avLst/>
+          </a:prstGeom>
+          <a:noFill/>
+        </p:spPr>
+        <p:txBody>
+          <a:bodyPr wrap="square">
+            <a:spAutoFit/>
+          </a:bodyPr>
+          <a:lstStyle/>
+          <a:p>
+            <a:pPr>
+              <a:spcAft>
+                <a:spcPts val="200"/>
+              </a:spcAft>
+              <a:defRPr sz="1000">
+                <a:solidFill>
+                  <a:srgbClr val="6B7280"/>
+                </a:solidFill>
+                <a:latin typeface="Calibri"/>
+              </a:defRPr>
+            </a:pPr>
+            <a:r>
+              <a:t>Enhanced Edge-Fog-Cloud</a:t>
+            </a:r>
+          </a:p>
+          <a:p>
+            <a:pPr>
+              <a:spcAft>
+                <a:spcPts val="200"/>
+              </a:spcAft>
+              <a:defRPr sz="1000">
+                <a:solidFill>
+                  <a:srgbClr val="6B7280"/>
+                </a:solidFill>
+                <a:latin typeface="Calibri"/>
+              </a:defRPr>
+            </a:pPr>
+            <a:r>
+              <a:t>  SNNs at edge → fog aggregation →</a:t>
+            </a:r>
+          </a:p>
+          <a:p>
+            <a:pPr>
+              <a:spcAft>
+                <a:spcPts val="200"/>
+              </a:spcAft>
+              <a:defRPr sz="1000">
+                <a:solidFill>
+                  <a:srgbClr val="6B7280"/>
+                </a:solidFill>
+                <a:latin typeface="Calibri"/>
+              </a:defRPr>
+            </a:pPr>
+            <a:r>
+              <a:t>  cloud Twin simulation + ML training</a:t>
+            </a:r>
+          </a:p>
+          <a:p>
+            <a:pPr>
+              <a:spcAft>
+                <a:spcPts val="200"/>
+              </a:spcAft>
+              <a:defRPr sz="1000">
+                <a:solidFill>
+                  <a:srgbClr val="6B7280"/>
+                </a:solidFill>
+                <a:latin typeface="Calibri"/>
+              </a:defRPr>
+            </a:pPr>
+            <a:r>
+              <a:t>  + cross-site federation</a:t>
+            </a:r>
+          </a:p>
+          <a:p>
+            <a:pPr>
+              <a:spcAft>
+                <a:spcPts val="200"/>
+              </a:spcAft>
+              <a:defRPr sz="1000">
+                <a:solidFill>
+                  <a:srgbClr val="6B7280"/>
+                </a:solidFill>
+                <a:latin typeface="Calibri"/>
+              </a:defRPr>
+            </a:pPr>
+          </a:p>
+          <a:p>
+            <a:pPr>
+              <a:spcAft>
+                <a:spcPts val="200"/>
+              </a:spcAft>
+              <a:defRPr sz="1000">
+                <a:solidFill>
+                  <a:srgbClr val="6B7280"/>
+                </a:solidFill>
+                <a:latin typeface="Calibri"/>
+              </a:defRPr>
+            </a:pPr>
+            <a:r>
+              <a:t>Digital Twin Federation</a:t>
+            </a:r>
+          </a:p>
+          <a:p>
+            <a:pPr>
+              <a:spcAft>
+                <a:spcPts val="200"/>
+              </a:spcAft>
+              <a:defRPr sz="1000">
+                <a:solidFill>
+                  <a:srgbClr val="6B7280"/>
+                </a:solidFill>
+                <a:latin typeface="Calibri"/>
+              </a:defRPr>
+            </a:pPr>
+            <a:r>
+              <a:t>  Hierarchical twinning: room → building</a:t>
+            </a:r>
+          </a:p>
+          <a:p>
+            <a:pPr>
+              <a:spcAft>
+                <a:spcPts val="200"/>
+              </a:spcAft>
+              <a:defRPr sz="1000">
+                <a:solidFill>
+                  <a:srgbClr val="6B7280"/>
+                </a:solidFill>
+                <a:latin typeface="Calibri"/>
+              </a:defRPr>
+            </a:pPr>
+            <a:r>
+              <a:t>  → campus → city level — multi-scale</a:t>
+            </a:r>
+          </a:p>
+          <a:p>
+            <a:pPr>
+              <a:spcAft>
+                <a:spcPts val="200"/>
+              </a:spcAft>
+              <a:defRPr sz="1000">
+                <a:solidFill>
+                  <a:srgbClr val="6B7280"/>
+                </a:solidFill>
+                <a:latin typeface="Calibri"/>
+              </a:defRPr>
+            </a:pPr>
+            <a:r>
+              <a:t>  simulation and policy planning</a:t>
+            </a:r>
+          </a:p>
+          <a:p>
+            <a:pPr>
+              <a:spcAft>
+                <a:spcPts val="200"/>
+              </a:spcAft>
+              <a:defRPr sz="1000">
+                <a:solidFill>
+                  <a:srgbClr val="6B7280"/>
+                </a:solidFill>
+                <a:latin typeface="Calibri"/>
+              </a:defRPr>
+            </a:pPr>
+          </a:p>
+          <a:p>
+            <a:pPr>
+              <a:spcAft>
+                <a:spcPts val="200"/>
+              </a:spcAft>
+              <a:defRPr sz="1000">
+                <a:solidFill>
+                  <a:srgbClr val="6B7280"/>
+                </a:solidFill>
+                <a:latin typeface="Calibri"/>
+              </a:defRPr>
+            </a:pPr>
+            <a:r>
+              <a:t>Swarm Intelligence</a:t>
+            </a:r>
+          </a:p>
+          <a:p>
+            <a:pPr>
+              <a:spcAft>
+                <a:spcPts val="200"/>
+              </a:spcAft>
+              <a:defRPr sz="1000">
+                <a:solidFill>
+                  <a:srgbClr val="6B7280"/>
+                </a:solidFill>
+                <a:latin typeface="Calibri"/>
+              </a:defRPr>
+            </a:pPr>
+            <a:r>
+              <a:t>  Multi-AYNO Bot coordination — shared</a:t>
+            </a:r>
+          </a:p>
+          <a:p>
+            <a:pPr>
+              <a:spcAft>
+                <a:spcPts val="200"/>
+              </a:spcAft>
+              <a:defRPr sz="1000">
+                <a:solidFill>
+                  <a:srgbClr val="6B7280"/>
+                </a:solidFill>
+                <a:latin typeface="Calibri"/>
+              </a:defRPr>
+            </a:pPr>
+            <a:r>
+              <a:t>  mapping, distributed task allocation,</a:t>
+            </a:r>
+          </a:p>
+          <a:p>
+            <a:pPr>
+              <a:spcAft>
+                <a:spcPts val="200"/>
+              </a:spcAft>
+              <a:defRPr sz="1000">
+                <a:solidFill>
+                  <a:srgbClr val="6B7280"/>
+                </a:solidFill>
+                <a:latin typeface="Calibri"/>
+              </a:defRPr>
+            </a:pPr>
+            <a:r>
+              <a:t>  coverage optimization for large areas</a:t>
+            </a:r>
+          </a:p>
+        </p:txBody>
+      </p:sp>
+      <p:sp>
+        <p:nvSpPr>
+          <p:cNvPr id="18" name="TextBox 17"/>
+          <p:cNvSpPr txBox="1"/>
+          <p:nvPr/>
+        </p:nvSpPr>
+        <p:spPr>
+          <a:xfrm>
+            <a:off x="11155680" y="6446520"/>
+            <a:ext cx="914400" cy="365760"/>
+          </a:xfrm>
+          <a:prstGeom prst="rect">
+            <a:avLst/>
+          </a:prstGeom>
+          <a:noFill/>
+        </p:spPr>
+        <p:txBody>
+          <a:bodyPr wrap="square">
+            <a:spAutoFit/>
+          </a:bodyPr>
+          <a:lstStyle/>
+          <a:p>
+            <a:pPr algn="r">
+              <a:defRPr sz="1000" b="0">
+                <a:solidFill>
+                  <a:srgbClr val="6B7280"/>
+                </a:solidFill>
+                <a:latin typeface="Calibri"/>
+              </a:defRPr>
+            </a:pPr>
+            <a:r>
+              <a:t>15/16</a:t>
+            </a:r>
+          </a:p>
+        </p:txBody>
+      </p:sp>
+    </p:spTree>
+  </p:cSld>
+  <p:clrMapOvr>
+    <a:masterClrMapping/>
+  </p:clrMapOvr>
+</p:sld>
+</file>
+
+<file path=ppt/slides/slide16.xml><?xml version="1.0" encoding="utf-8"?>
 <p:sld xmlns:a="http://schemas.openxmlformats.org/drawingml/2006/main" xmlns:p="http://schemas.openxmlformats.org/presentationml/2006/main" xmlns:r="http://schemas.openxmlformats.org/officeDocument/2006/relationships">
   <p:cSld>
     <p:bg>
@@ -11727,7 +14138,7 @@
               </a:defRPr>
             </a:pPr>
             <a:r>
-              <a:t>14/14</a:t>
+              <a:t>16/16</a:t>
             </a:r>
           </a:p>
         </p:txBody>
@@ -13113,7 +15524,7 @@
               </a:defRPr>
             </a:pPr>
             <a:r>
-              <a:t>2/14</a:t>
+              <a:t>2/16</a:t>
             </a:r>
           </a:p>
         </p:txBody>
@@ -14685,7 +17096,7 @@
               </a:defRPr>
             </a:pPr>
             <a:r>
-              <a:t>3/14</a:t>
+              <a:t>3/16</a:t>
             </a:r>
           </a:p>
         </p:txBody>
@@ -15631,7 +18042,7 @@
               </a:defRPr>
             </a:pPr>
             <a:r>
-              <a:t>4/14</a:t>
+              <a:t>4/16</a:t>
             </a:r>
           </a:p>
         </p:txBody>
@@ -17549,7 +19960,7 @@
               </a:defRPr>
             </a:pPr>
             <a:r>
-              <a:t>5/14</a:t>
+              <a:t>5/16</a:t>
             </a:r>
           </a:p>
         </p:txBody>
@@ -18517,7 +20928,7 @@
               </a:defRPr>
             </a:pPr>
             <a:r>
-              <a:t>6/14</a:t>
+              <a:t>6/16</a:t>
             </a:r>
           </a:p>
         </p:txBody>
@@ -20182,7 +22593,7 @@
               </a:defRPr>
             </a:pPr>
             <a:r>
-              <a:t>7/14</a:t>
+              <a:t>7/16</a:t>
             </a:r>
           </a:p>
         </p:txBody>
@@ -21120,7 +23531,7 @@
               </a:defRPr>
             </a:pPr>
             <a:r>
-              <a:t>8/14</a:t>
+              <a:t>8/16</a:t>
             </a:r>
           </a:p>
         </p:txBody>
@@ -22580,7 +24991,7 @@
               </a:defRPr>
             </a:pPr>
             <a:r>
-              <a:t>9/14</a:t>
+              <a:t>9/16</a:t>
             </a:r>
           </a:p>
         </p:txBody>

</xml_diff>